<commit_message>
feat(deck): le cadran du coffre à côté du titre
Le logo du front (.ink-logo dans index.html) reprend sa place sur la
première et la dernière diapositive, dans les deux supports.

Le HTML inline le SVG tel quel — même viewBox, même tracé, et
`currentColor` le fait suivre la couleur du titre. Le .pptx le
reconstruit en formes natives (trois cercles + l'index à midi) en
convertissant les coordonnées du viewBox 40×40 plutôt qu'en retraçant à
vue, pour que les deux restent identiques si le logo bouge.

Co-Authored-By: Claude Opus 5 (1M context) <noreply@anthropic.com>
Claude-Session: https://claude.ai/code/session_01YPeeUmkMcuQzcsWgCisrB9
</commit_message>
<xml_diff>
--- a/SecondWave.pptx
+++ b/SecondWave.pptx
@@ -3403,14 +3403,191 @@
       </p:sp>
       <p:sp>
         <p:nvSpPr>
-          <p:cNvPr id="10" name="TextBox 9"/>
+          <p:cNvPr id="10" name="Oval 9"/>
+          <p:cNvSpPr/>
+          <p:nvPr/>
+        </p:nvSpPr>
+        <p:spPr>
+          <a:xfrm>
+            <a:off x="927658" y="1933498"/>
+            <a:ext cx="668426" cy="668426"/>
+          </a:xfrm>
+          <a:prstGeom prst="ellipse">
+            <a:avLst/>
+          </a:prstGeom>
+          <a:noFill/>
+          <a:ln w="31455">
+            <a:solidFill>
+              <a:srgbClr val="F1F1F3"/>
+            </a:solidFill>
+          </a:ln>
+          <a:effectLst/>
+        </p:spPr>
+        <p:style>
+          <a:lnRef idx="1">
+            <a:schemeClr val="accent1"/>
+          </a:lnRef>
+          <a:fillRef idx="3">
+            <a:schemeClr val="accent1"/>
+          </a:fillRef>
+          <a:effectRef idx="2">
+            <a:schemeClr val="accent1"/>
+          </a:effectRef>
+          <a:fontRef idx="minor">
+            <a:schemeClr val="lt1"/>
+          </a:fontRef>
+        </p:style>
+        <p:txBody>
+          <a:bodyPr rtlCol="0" anchor="ctr"/>
+          <a:lstStyle/>
+          <a:p>
+            <a:pPr algn="ctr"/>
+          </a:p>
+        </p:txBody>
+      </p:sp>
+      <p:sp>
+        <p:nvSpPr>
+          <p:cNvPr id="11" name="Oval 10"/>
+          <p:cNvSpPr/>
+          <p:nvPr/>
+        </p:nvSpPr>
+        <p:spPr>
+          <a:xfrm>
+            <a:off x="1016126" y="2021966"/>
+            <a:ext cx="491490" cy="491490"/>
+          </a:xfrm>
+          <a:prstGeom prst="ellipse">
+            <a:avLst/>
+          </a:prstGeom>
+          <a:noFill/>
+          <a:ln w="21625">
+            <a:solidFill>
+              <a:srgbClr val="F1F1F3"/>
+            </a:solidFill>
+            <a:prstDash val="sysDot"/>
+          </a:ln>
+          <a:effectLst/>
+        </p:spPr>
+        <p:style>
+          <a:lnRef idx="1">
+            <a:schemeClr val="accent1"/>
+          </a:lnRef>
+          <a:fillRef idx="3">
+            <a:schemeClr val="accent1"/>
+          </a:fillRef>
+          <a:effectRef idx="2">
+            <a:schemeClr val="accent1"/>
+          </a:effectRef>
+          <a:fontRef idx="minor">
+            <a:schemeClr val="lt1"/>
+          </a:fontRef>
+        </p:style>
+        <p:txBody>
+          <a:bodyPr rtlCol="0" anchor="ctr"/>
+          <a:lstStyle/>
+          <a:p>
+            <a:pPr algn="ctr"/>
+          </a:p>
+        </p:txBody>
+      </p:sp>
+      <p:sp>
+        <p:nvSpPr>
+          <p:cNvPr id="12" name="Oval 11"/>
+          <p:cNvSpPr/>
+          <p:nvPr/>
+        </p:nvSpPr>
+        <p:spPr>
+          <a:xfrm>
+            <a:off x="1173403" y="2179243"/>
+            <a:ext cx="176936" cy="176936"/>
+          </a:xfrm>
+          <a:prstGeom prst="ellipse">
+            <a:avLst/>
+          </a:prstGeom>
+          <a:solidFill>
+            <a:srgbClr val="F1F1F3"/>
+          </a:solidFill>
+          <a:ln>
+            <a:noFill/>
+          </a:ln>
+          <a:effectLst/>
+        </p:spPr>
+        <p:style>
+          <a:lnRef idx="1">
+            <a:schemeClr val="accent1"/>
+          </a:lnRef>
+          <a:fillRef idx="3">
+            <a:schemeClr val="accent1"/>
+          </a:fillRef>
+          <a:effectRef idx="2">
+            <a:schemeClr val="accent1"/>
+          </a:effectRef>
+          <a:fontRef idx="minor">
+            <a:schemeClr val="lt1"/>
+          </a:fontRef>
+        </p:style>
+        <p:txBody>
+          <a:bodyPr rtlCol="0" anchor="ctr"/>
+          <a:lstStyle/>
+          <a:p>
+            <a:pPr algn="ctr"/>
+          </a:p>
+        </p:txBody>
+      </p:sp>
+      <p:sp>
+        <p:nvSpPr>
+          <p:cNvPr id="13" name="Rectangle 12"/>
+          <p:cNvSpPr/>
+          <p:nvPr/>
+        </p:nvSpPr>
+        <p:spPr>
+          <a:xfrm>
+            <a:off x="1250076" y="1943328"/>
+            <a:ext cx="23591" cy="117957"/>
+          </a:xfrm>
+          <a:prstGeom prst="rect">
+            <a:avLst/>
+          </a:prstGeom>
+          <a:solidFill>
+            <a:srgbClr val="F1F1F3"/>
+          </a:solidFill>
+          <a:ln>
+            <a:noFill/>
+          </a:ln>
+          <a:effectLst/>
+        </p:spPr>
+        <p:style>
+          <a:lnRef idx="1">
+            <a:schemeClr val="accent1"/>
+          </a:lnRef>
+          <a:fillRef idx="3">
+            <a:schemeClr val="accent1"/>
+          </a:fillRef>
+          <a:effectRef idx="2">
+            <a:schemeClr val="accent1"/>
+          </a:effectRef>
+          <a:fontRef idx="minor">
+            <a:schemeClr val="lt1"/>
+          </a:fontRef>
+        </p:style>
+        <p:txBody>
+          <a:bodyPr rtlCol="0" anchor="ctr"/>
+          <a:lstStyle/>
+          <a:p>
+            <a:pPr algn="ctr"/>
+          </a:p>
+        </p:txBody>
+      </p:sp>
+      <p:sp>
+        <p:nvSpPr>
+          <p:cNvPr id="14" name="TextBox 13"/>
           <p:cNvSpPr txBox="1"/>
           <p:nvPr/>
         </p:nvSpPr>
         <p:spPr>
           <a:xfrm>
-            <a:off x="868680" y="1828800"/>
-            <a:ext cx="10058400" cy="1371600"/>
+            <a:off x="1874519" y="1828800"/>
+            <a:ext cx="9144000" cy="1371600"/>
           </a:xfrm>
           <a:prstGeom prst="rect">
             <a:avLst/>
@@ -3437,7 +3614,7 @@
       </p:sp>
       <p:sp>
         <p:nvSpPr>
-          <p:cNvPr id="11" name="TextBox 10"/>
+          <p:cNvPr id="15" name="TextBox 14"/>
           <p:cNvSpPr txBox="1"/>
           <p:nvPr/>
         </p:nvSpPr>
@@ -3479,7 +3656,7 @@
       </p:sp>
       <p:sp>
         <p:nvSpPr>
-          <p:cNvPr id="12" name="TextBox 11"/>
+          <p:cNvPr id="16" name="TextBox 15"/>
           <p:cNvSpPr txBox="1"/>
           <p:nvPr/>
         </p:nvSpPr>
@@ -3552,7 +3729,7 @@
       </p:sp>
       <p:sp>
         <p:nvSpPr>
-          <p:cNvPr id="13" name="TextBox 12"/>
+          <p:cNvPr id="17" name="TextBox 16"/>
           <p:cNvSpPr txBox="1"/>
           <p:nvPr/>
         </p:nvSpPr>
@@ -3586,7 +3763,7 @@
       </p:sp>
       <p:sp>
         <p:nvSpPr>
-          <p:cNvPr id="14" name="TextBox 13"/>
+          <p:cNvPr id="18" name="TextBox 17"/>
           <p:cNvSpPr txBox="1"/>
           <p:nvPr/>
         </p:nvSpPr>
@@ -7381,14 +7558,191 @@
       </p:sp>
       <p:sp>
         <p:nvSpPr>
-          <p:cNvPr id="10" name="TextBox 9"/>
+          <p:cNvPr id="10" name="Oval 9"/>
+          <p:cNvSpPr/>
+          <p:nvPr/>
+        </p:nvSpPr>
+        <p:spPr>
+          <a:xfrm>
+            <a:off x="916686" y="1949958"/>
+            <a:ext cx="544068" cy="544068"/>
+          </a:xfrm>
+          <a:prstGeom prst="ellipse">
+            <a:avLst/>
+          </a:prstGeom>
+          <a:noFill/>
+          <a:ln w="25603">
+            <a:solidFill>
+              <a:srgbClr val="F1F1F3"/>
+            </a:solidFill>
+          </a:ln>
+          <a:effectLst/>
+        </p:spPr>
+        <p:style>
+          <a:lnRef idx="1">
+            <a:schemeClr val="accent1"/>
+          </a:lnRef>
+          <a:fillRef idx="3">
+            <a:schemeClr val="accent1"/>
+          </a:fillRef>
+          <a:effectRef idx="2">
+            <a:schemeClr val="accent1"/>
+          </a:effectRef>
+          <a:fontRef idx="minor">
+            <a:schemeClr val="lt1"/>
+          </a:fontRef>
+        </p:style>
+        <p:txBody>
+          <a:bodyPr rtlCol="0" anchor="ctr"/>
+          <a:lstStyle/>
+          <a:p>
+            <a:pPr algn="ctr"/>
+          </a:p>
+        </p:txBody>
+      </p:sp>
+      <p:sp>
+        <p:nvSpPr>
+          <p:cNvPr id="11" name="Oval 10"/>
+          <p:cNvSpPr/>
+          <p:nvPr/>
+        </p:nvSpPr>
+        <p:spPr>
+          <a:xfrm>
+            <a:off x="988694" y="2021967"/>
+            <a:ext cx="400049" cy="400049"/>
+          </a:xfrm>
+          <a:prstGeom prst="ellipse">
+            <a:avLst/>
+          </a:prstGeom>
+          <a:noFill/>
+          <a:ln w="17602">
+            <a:solidFill>
+              <a:srgbClr val="F1F1F3"/>
+            </a:solidFill>
+            <a:prstDash val="sysDot"/>
+          </a:ln>
+          <a:effectLst/>
+        </p:spPr>
+        <p:style>
+          <a:lnRef idx="1">
+            <a:schemeClr val="accent1"/>
+          </a:lnRef>
+          <a:fillRef idx="3">
+            <a:schemeClr val="accent1"/>
+          </a:fillRef>
+          <a:effectRef idx="2">
+            <a:schemeClr val="accent1"/>
+          </a:effectRef>
+          <a:fontRef idx="minor">
+            <a:schemeClr val="lt1"/>
+          </a:fontRef>
+        </p:style>
+        <p:txBody>
+          <a:bodyPr rtlCol="0" anchor="ctr"/>
+          <a:lstStyle/>
+          <a:p>
+            <a:pPr algn="ctr"/>
+          </a:p>
+        </p:txBody>
+      </p:sp>
+      <p:sp>
+        <p:nvSpPr>
+          <p:cNvPr id="12" name="Oval 11"/>
+          <p:cNvSpPr/>
+          <p:nvPr/>
+        </p:nvSpPr>
+        <p:spPr>
+          <a:xfrm>
+            <a:off x="1116711" y="2149983"/>
+            <a:ext cx="144017" cy="144017"/>
+          </a:xfrm>
+          <a:prstGeom prst="ellipse">
+            <a:avLst/>
+          </a:prstGeom>
+          <a:solidFill>
+            <a:srgbClr val="F1F1F3"/>
+          </a:solidFill>
+          <a:ln>
+            <a:noFill/>
+          </a:ln>
+          <a:effectLst/>
+        </p:spPr>
+        <p:style>
+          <a:lnRef idx="1">
+            <a:schemeClr val="accent1"/>
+          </a:lnRef>
+          <a:fillRef idx="3">
+            <a:schemeClr val="accent1"/>
+          </a:fillRef>
+          <a:effectRef idx="2">
+            <a:schemeClr val="accent1"/>
+          </a:effectRef>
+          <a:fontRef idx="minor">
+            <a:schemeClr val="lt1"/>
+          </a:fontRef>
+        </p:style>
+        <p:txBody>
+          <a:bodyPr rtlCol="0" anchor="ctr"/>
+          <a:lstStyle/>
+          <a:p>
+            <a:pPr algn="ctr"/>
+          </a:p>
+        </p:txBody>
+      </p:sp>
+      <p:sp>
+        <p:nvSpPr>
+          <p:cNvPr id="13" name="Rectangle 12"/>
+          <p:cNvSpPr/>
+          <p:nvPr/>
+        </p:nvSpPr>
+        <p:spPr>
+          <a:xfrm>
+            <a:off x="1179118" y="1957959"/>
+            <a:ext cx="19202" cy="96011"/>
+          </a:xfrm>
+          <a:prstGeom prst="rect">
+            <a:avLst/>
+          </a:prstGeom>
+          <a:solidFill>
+            <a:srgbClr val="F1F1F3"/>
+          </a:solidFill>
+          <a:ln>
+            <a:noFill/>
+          </a:ln>
+          <a:effectLst/>
+        </p:spPr>
+        <p:style>
+          <a:lnRef idx="1">
+            <a:schemeClr val="accent1"/>
+          </a:lnRef>
+          <a:fillRef idx="3">
+            <a:schemeClr val="accent1"/>
+          </a:fillRef>
+          <a:effectRef idx="2">
+            <a:schemeClr val="accent1"/>
+          </a:effectRef>
+          <a:fontRef idx="minor">
+            <a:schemeClr val="lt1"/>
+          </a:fontRef>
+        </p:style>
+        <p:txBody>
+          <a:bodyPr rtlCol="0" anchor="ctr"/>
+          <a:lstStyle/>
+          <a:p>
+            <a:pPr algn="ctr"/>
+          </a:p>
+        </p:txBody>
+      </p:sp>
+      <p:sp>
+        <p:nvSpPr>
+          <p:cNvPr id="14" name="TextBox 13"/>
           <p:cNvSpPr txBox="1"/>
           <p:nvPr/>
         </p:nvSpPr>
         <p:spPr>
           <a:xfrm>
-            <a:off x="868680" y="1828800"/>
-            <a:ext cx="10058400" cy="1097280"/>
+            <a:off x="1673352" y="1828800"/>
+            <a:ext cx="9144000" cy="1097280"/>
           </a:xfrm>
           <a:prstGeom prst="rect">
             <a:avLst/>
@@ -7415,7 +7769,7 @@
       </p:sp>
       <p:sp>
         <p:nvSpPr>
-          <p:cNvPr id="11" name="Rounded Rectangle 10"/>
+          <p:cNvPr id="15" name="Rounded Rectangle 14"/>
           <p:cNvSpPr/>
           <p:nvPr/>
         </p:nvSpPr>
@@ -7461,7 +7815,7 @@
       </p:sp>
       <p:sp>
         <p:nvSpPr>
-          <p:cNvPr id="12" name="TextBox 11"/>
+          <p:cNvPr id="16" name="TextBox 15"/>
           <p:cNvSpPr txBox="1"/>
           <p:nvPr/>
         </p:nvSpPr>
@@ -7511,7 +7865,7 @@
       </p:sp>
       <p:sp>
         <p:nvSpPr>
-          <p:cNvPr id="13" name="Rounded Rectangle 12"/>
+          <p:cNvPr id="17" name="Rounded Rectangle 16"/>
           <p:cNvSpPr/>
           <p:nvPr/>
         </p:nvSpPr>
@@ -7557,7 +7911,7 @@
       </p:sp>
       <p:sp>
         <p:nvSpPr>
-          <p:cNvPr id="14" name="TextBox 13"/>
+          <p:cNvPr id="18" name="TextBox 17"/>
           <p:cNvSpPr txBox="1"/>
           <p:nvPr/>
         </p:nvSpPr>
@@ -7607,7 +7961,7 @@
       </p:sp>
       <p:sp>
         <p:nvSpPr>
-          <p:cNvPr id="15" name="TextBox 14"/>
+          <p:cNvPr id="19" name="TextBox 18"/>
           <p:cNvSpPr txBox="1"/>
           <p:nvPr/>
         </p:nvSpPr>
@@ -7658,7 +8012,7 @@
       </p:sp>
       <p:sp>
         <p:nvSpPr>
-          <p:cNvPr id="16" name="TextBox 15"/>
+          <p:cNvPr id="20" name="TextBox 19"/>
           <p:cNvSpPr txBox="1"/>
           <p:nvPr/>
         </p:nvSpPr>

</xml_diff>